<commit_message>
BEBO 2.0: GPT-OSS 120B brain, themes, hotkey remapping, update alerts
- Migrate AI from llama-3.3-70b-versatile (Groq retires all Llama models
  2026-08-16) to GPT-OSS 120B with GPT-OSS 20B automatic fallback
- Per-action button colors in the panel
- Dark/Light theme toggle, persisted in config
- Custom hotkey remapping UI; default hide moved Ctrl+Shift+H -> Ctrl+Shift+B
  so Win+H stays free for Windows voice typing
- Voice input hint (Win+H dictation) in the input section
- Multi-monitor: wake snaps BEBO to the active monitor
- Update checker against GitHub releases + What's New popup
- Docs/site/carousel truth sweep: model name, 1,000 req/day free limit,
  ~500 tok/s measured speed, evergreen releases/latest links

Co-Authored-By: Claude Fable 5 <noreply@anthropic.com>
</commit_message>
<xml_diff>
--- a/BEBO-Pitch-Deck.pptx
+++ b/BEBO-Pitch-Deck.pptx
@@ -5,7 +5,7 @@
     <p:sldMasterId id="2147483648" r:id="rId1"/>
   </p:sldMasterIdLst>
   <p:notesMasterIdLst>
-    <p:notesMasterId r:id="rId20"/>
+    <p:notesMasterId r:id="rId21"/>
   </p:notesMasterIdLst>
   <p:sldIdLst>
     <p:sldId id="256" r:id="rId2"/>
@@ -26,6 +26,7 @@
     <p:sldId id="271" r:id="rId17"/>
     <p:sldId id="272" r:id="rId18"/>
     <p:sldId id="273" r:id="rId19"/>
+    <p:sldId id="276" r:id="rId20"/>
   </p:sldIdLst>
   <p:sldSz cx="9144000" cy="5143500" type="screen16x9"/>
   <p:notesSz cx="5143500" cy="9144000"/>
@@ -14124,6 +14125,1347 @@
         </p:txBody>
       </p:sp>
     </p:spTree>
+  </p:cSld>
+  <p:clrMapOvr>
+    <a:masterClrMapping/>
+  </p:clrMapOvr>
+</p:sld>
+</file>
+
+<file path=ppt/slides/slide19.xml><?xml version="1.0" encoding="utf-8"?>
+<p:sld xmlns:a="http://schemas.openxmlformats.org/drawingml/2006/main" xmlns:r="http://schemas.openxmlformats.org/officeDocument/2006/relationships" xmlns:p="http://schemas.openxmlformats.org/presentationml/2006/main">
+  <p:cSld name="Slide 19">
+    <p:bg>
+      <p:bgPr>
+        <a:solidFill>
+          <a:srgbClr val="12131F"/>
+        </a:solidFill>
+        <a:effectLst/>
+      </p:bgPr>
+    </p:bg>
+    <p:spTree>
+      <p:nvGrpSpPr>
+        <p:cNvPr id="1" name=""/>
+        <p:cNvGrpSpPr/>
+        <p:nvPr/>
+      </p:nvGrpSpPr>
+      <p:grpSpPr>
+        <a:xfrm>
+          <a:off x="0" y="0"/>
+          <a:ext cx="0" cy="0"/>
+          <a:chOff x="0" y="0"/>
+          <a:chExt cx="0" cy="0"/>
+        </a:xfrm>
+      </p:grpSpPr>
+      <p:sp>
+        <p:nvSpPr>
+          <p:cNvPr id="11" name="Glow"/>
+          <p:cNvSpPr/>
+          <p:nvPr/>
+        </p:nvSpPr>
+        <p:spPr>
+          <a:xfrm>
+            <a:off x="5486400" y="-457200"/>
+            <a:ext cx="3657600" cy="3657600"/>
+          </a:xfrm>
+          <a:prstGeom prst="rect">
+            <a:avLst/>
+          </a:prstGeom>
+          <a:solidFill>
+            <a:srgbClr val="7C5CFC">
+              <a:alpha val="8000"/>
+            </a:srgbClr>
+          </a:solidFill>
+          <a:ln>
+            <a:noFill/>
+          </a:ln>
+        </p:spPr>
+        <p:txBody>
+          <a:bodyPr/>
+          <a:lstStyle/>
+          <a:p>
+            <a:endParaRPr lang="en-US"/>
+          </a:p>
+        </p:txBody>
+      </p:sp>
+      <p:sp>
+        <p:nvSpPr>
+          <p:cNvPr id="12" name="Title"/>
+          <p:cNvSpPr txBox="1"/>
+          <p:nvPr/>
+        </p:nvSpPr>
+        <p:spPr>
+          <a:xfrm>
+            <a:off x="457200" y="152400"/>
+            <a:ext cx="8229600" cy="533400"/>
+          </a:xfrm>
+          <a:prstGeom prst="rect">
+            <a:avLst/>
+          </a:prstGeom>
+          <a:noFill/>
+          <a:ln>
+            <a:noFill/>
+          </a:ln>
+        </p:spPr>
+        <p:txBody>
+          <a:bodyPr wrap="square" anchor="t">
+            <a:noAutofit/>
+          </a:bodyPr>
+          <a:lstStyle/>
+          <a:p>
+            <a:pPr algn="l">
+              <a:spcAft>
+                <a:spcPts val="100"/>
+              </a:spcAft>
+            </a:pPr>
+            <a:r>
+              <a:rPr lang="en-US" sz="3200" b="1" dirty="0">
+                <a:solidFill>
+                  <a:srgbClr val="EEF2FF"/>
+                </a:solidFill>
+                <a:latin typeface="Calibri"/>
+              </a:rPr>
+              <a:t>BEBO is the Fastest AI Workflow — By Far</a:t>
+            </a:r>
+          </a:p>
+        </p:txBody>
+      </p:sp>
+      <p:sp>
+        <p:nvSpPr>
+          <p:cNvPr id="13" name="LCard"/>
+          <p:cNvSpPr/>
+          <p:nvPr/>
+        </p:nvSpPr>
+        <p:spPr>
+          <a:xfrm>
+            <a:off x="411480" y="762000"/>
+            <a:ext cx="3977640" cy="2286000"/>
+          </a:xfrm>
+          <a:prstGeom prst="rect">
+            <a:avLst/>
+          </a:prstGeom>
+          <a:solidFill>
+            <a:srgbClr val="16172A"/>
+          </a:solidFill>
+          <a:ln w="9525">
+            <a:solidFill>
+              <a:srgbClr val="2A2B40"/>
+            </a:solidFill>
+          </a:ln>
+        </p:spPr>
+        <p:txBody>
+          <a:bodyPr/>
+          <a:lstStyle/>
+          <a:p>
+            <a:endParaRPr lang="en-US"/>
+          </a:p>
+        </p:txBody>
+      </p:sp>
+      <p:sp>
+        <p:nvSpPr>
+          <p:cNvPr id="14" name="LHdr"/>
+          <p:cNvSpPr txBox="1"/>
+          <p:nvPr/>
+        </p:nvSpPr>
+        <p:spPr>
+          <a:xfrm>
+            <a:off x="457200" y="776000"/>
+            <a:ext cx="3886200" cy="280000"/>
+          </a:xfrm>
+          <a:prstGeom prst="rect">
+            <a:avLst/>
+          </a:prstGeom>
+          <a:noFill/>
+          <a:ln>
+            <a:noFill/>
+          </a:ln>
+        </p:spPr>
+        <p:txBody>
+          <a:bodyPr wrap="square" anchor="t">
+            <a:noAutofit/>
+          </a:bodyPr>
+          <a:lstStyle/>
+          <a:p>
+            <a:pPr algn="l">
+              <a:spcAft>
+                <a:spcPts val="100"/>
+              </a:spcAft>
+            </a:pPr>
+            <a:r>
+              <a:rPr lang="en-US" sz="1600" b="1" dirty="0">
+                <a:solidFill>
+                  <a:srgbClr val="A78BFA"/>
+                </a:solidFill>
+                <a:latin typeface="Calibri"/>
+              </a:rPr>
+              <a:t>⚡ API Response Speed</a:t>
+            </a:r>
+          </a:p>
+        </p:txBody>
+      </p:sp>
+      <p:graphicFrame>
+        <p:nvGraphicFramePr>
+          <p:cNvPr id="15" name="APITable"/>
+          <p:cNvGraphicFramePr>
+            <a:graphicFrameLocks noGrp="1"/>
+          </p:cNvGraphicFramePr>
+          <p:nvPr/>
+        </p:nvGraphicFramePr>
+        <p:xfrm>
+          <a:off x="457200" y="1080000"/>
+          <a:ext cx="3886200" cy="2076720"/>
+        </p:xfrm>
+        <a:graphic>
+          <a:graphicData uri="http://schemas.openxmlformats.org/drawingml/2006/table">
+            <a:tbl>
+              <a:tblPr/>
+              <a:tblGrid>
+                <a:gridCol w="2100000">
+                  <a:extLst>
+                    <a:ext uri="{9D8B030D-6E8A-4147-A177-3AD203B41FA5}">
+                      <a16:colId xmlns:a16="http://schemas.microsoft.com/office/drawing/2014/main" val="20000"/>
+                    </a:ext>
+                  </a:extLst>
+                </a:gridCol>
+                <a:gridCol w="886200">
+                  <a:extLst>
+                    <a:ext uri="{9D8B030D-6E8A-4147-A177-3AD203B41FA5}">
+                      <a16:colId xmlns:a16="http://schemas.microsoft.com/office/drawing/2014/main" val="20001"/>
+                    </a:ext>
+                  </a:extLst>
+                </a:gridCol>
+                <a:gridCol w="900000">
+                  <a:extLst>
+                    <a:ext uri="{9D8B030D-6E8A-4147-A177-3AD203B41FA5}">
+                      <a16:colId xmlns:a16="http://schemas.microsoft.com/office/drawing/2014/main" val="20002"/>
+                    </a:ext>
+                  </a:extLst>
+                </a:gridCol>
+              </a:tblGrid>
+              <a:tr h="320000">
+                <a:tc>
+                  <a:txBody>
+                    <a:bodyPr/>
+                    <a:lstStyle/>
+                    <a:p>
+                      <a:pPr algn="l"/>
+                      <a:r>
+                        <a:rPr lang="en-US" sz="1100" b="1" dirty="0">
+                          <a:solidFill>
+                            <a:srgbClr val="EEF2FF"/>
+                          </a:solidFill>
+                          <a:latin typeface="Calibri"/>
+                        </a:rPr>
+                        <a:t>Model</a:t>
+                      </a:r>
+                    </a:p>
+                  </a:txBody>
+                  <a:tcPr>
+                    <a:solidFill>
+                      <a:srgbClr val="1E1F35"/>
+                    </a:solidFill>
+                  </a:tcPr>
+                </a:tc>
+                <a:tc>
+                  <a:txBody>
+                    <a:bodyPr/>
+                    <a:lstStyle/>
+                    <a:p>
+                      <a:pPr algn="l"/>
+                      <a:r>
+                        <a:rPr lang="en-US" sz="1100" b="1" dirty="0">
+                          <a:solidFill>
+                            <a:srgbClr val="EEF2FF"/>
+                          </a:solidFill>
+                          <a:latin typeface="Calibri"/>
+                        </a:rPr>
+                        <a:t>Tok/s</a:t>
+                      </a:r>
+                    </a:p>
+                  </a:txBody>
+                  <a:tcPr>
+                    <a:solidFill>
+                      <a:srgbClr val="1E1F35"/>
+                    </a:solidFill>
+                  </a:tcPr>
+                </a:tc>
+                <a:tc>
+                  <a:txBody>
+                    <a:bodyPr/>
+                    <a:lstStyle/>
+                    <a:p>
+                      <a:pPr algn="l"/>
+                      <a:r>
+                        <a:rPr lang="en-US" sz="1100" b="1" dirty="0">
+                          <a:solidFill>
+                            <a:srgbClr val="EEF2FF"/>
+                          </a:solidFill>
+                          <a:latin typeface="Calibri"/>
+                        </a:rPr>
+                        <a:t>200-tok task</a:t>
+                      </a:r>
+                    </a:p>
+                  </a:txBody>
+                  <a:tcPr>
+                    <a:solidFill>
+                      <a:srgbClr val="1E1F35"/>
+                    </a:solidFill>
+                  </a:tcPr>
+                </a:tc>
+                <a:extLst>
+                  <a:ext uri="{0D108BD9-81ED-4DB2-BD59-A6C34878D82A}">
+                    <a16:rowId xmlns:a16="http://schemas.microsoft.com/office/drawing/2014/main" val="10000"/>
+                  </a:ext>
+                </a:extLst>
+              </a:tr>
+              <a:tr h="370000">
+                <a:tc>
+                  <a:txBody>
+                    <a:bodyPr/>
+                    <a:lstStyle/>
+                    <a:p>
+                      <a:pPr algn="l"/>
+                      <a:r>
+                        <a:rPr lang="en-US" sz="1050" b="1" dirty="0">
+                          <a:solidFill>
+                            <a:srgbClr val="A78BFA"/>
+                          </a:solidFill>
+                          <a:latin typeface="Calibri"/>
+                        </a:rPr>
+                        <a:t>BEBO  (Groq + Llama 3.3 70B)</a:t>
+                      </a:r>
+                    </a:p>
+                  </a:txBody>
+                  <a:tcPr>
+                    <a:solidFill>
+                      <a:srgbClr val="2D1B69"/>
+                    </a:solidFill>
+                  </a:tcPr>
+                </a:tc>
+                <a:tc>
+                  <a:txBody>
+                    <a:bodyPr/>
+                    <a:lstStyle/>
+                    <a:p>
+                      <a:pPr algn="l"/>
+                      <a:r>
+                        <a:rPr lang="en-US" sz="1050" b="1" dirty="0">
+                          <a:solidFill>
+                            <a:srgbClr val="6EE7B7"/>
+                          </a:solidFill>
+                          <a:latin typeface="Calibri"/>
+                        </a:rPr>
+                        <a:t>800–1000</a:t>
+                      </a:r>
+                    </a:p>
+                  </a:txBody>
+                  <a:tcPr>
+                    <a:solidFill>
+                      <a:srgbClr val="2D1B69"/>
+                    </a:solidFill>
+                  </a:tcPr>
+                </a:tc>
+                <a:tc>
+                  <a:txBody>
+                    <a:bodyPr/>
+                    <a:lstStyle/>
+                    <a:p>
+                      <a:pPr algn="l"/>
+                      <a:r>
+                        <a:rPr lang="en-US" sz="1050" b="1" dirty="0">
+                          <a:solidFill>
+                            <a:srgbClr val="6EE7B7"/>
+                          </a:solidFill>
+                          <a:latin typeface="Calibri"/>
+                        </a:rPr>
+                        <a:t>0.3–0.5s ★</a:t>
+                      </a:r>
+                    </a:p>
+                  </a:txBody>
+                  <a:tcPr>
+                    <a:solidFill>
+                      <a:srgbClr val="2D1B69"/>
+                    </a:solidFill>
+                  </a:tcPr>
+                </a:tc>
+                <a:extLst>
+                  <a:ext uri="{0D108BD9-81ED-4DB2-BD59-A6C34878D82A}">
+                    <a16:rowId xmlns:a16="http://schemas.microsoft.com/office/drawing/2014/main" val="10001"/>
+                  </a:ext>
+                </a:extLst>
+              </a:tr>
+              <a:tr h="320000">
+                <a:tc>
+                  <a:txBody>
+                    <a:bodyPr/>
+                    <a:lstStyle/>
+                    <a:p>
+                      <a:pPr algn="l"/>
+                      <a:r>
+                        <a:rPr lang="en-US" sz="1000" dirty="0">
+                          <a:solidFill>
+                            <a:srgbClr val="8B8FA8"/>
+                          </a:solidFill>
+                          <a:latin typeface="Calibri"/>
+                        </a:rPr>
+                        <a:t>Gemini 2.0 Flash</a:t>
+                      </a:r>
+                    </a:p>
+                  </a:txBody>
+                  <a:tcPr>
+                    <a:solidFill>
+                      <a:srgbClr val="16172A"/>
+                    </a:solidFill>
+                  </a:tcPr>
+                </a:tc>
+                <a:tc>
+                  <a:txBody>
+                    <a:bodyPr/>
+                    <a:lstStyle/>
+                    <a:p>
+                      <a:pPr algn="l"/>
+                      <a:r>
+                        <a:rPr lang="en-US" sz="1000" dirty="0">
+                          <a:solidFill>
+                            <a:srgbClr val="8B8FA8"/>
+                          </a:solidFill>
+                          <a:latin typeface="Calibri"/>
+                        </a:rPr>
+                        <a:t>~200–300</a:t>
+                      </a:r>
+                    </a:p>
+                  </a:txBody>
+                  <a:tcPr>
+                    <a:solidFill>
+                      <a:srgbClr val="16172A"/>
+                    </a:solidFill>
+                  </a:tcPr>
+                </a:tc>
+                <a:tc>
+                  <a:txBody>
+                    <a:bodyPr/>
+                    <a:lstStyle/>
+                    <a:p>
+                      <a:pPr algn="l"/>
+                      <a:r>
+                        <a:rPr lang="en-US" sz="1000" dirty="0">
+                          <a:solidFill>
+                            <a:srgbClr val="8B8FA8"/>
+                          </a:solidFill>
+                          <a:latin typeface="Calibri"/>
+                        </a:rPr>
+                        <a:t>0.8–1.2s</a:t>
+                      </a:r>
+                    </a:p>
+                  </a:txBody>
+                  <a:tcPr>
+                    <a:solidFill>
+                      <a:srgbClr val="16172A"/>
+                    </a:solidFill>
+                  </a:tcPr>
+                </a:tc>
+                <a:extLst>
+                  <a:ext uri="{0D108BD9-81ED-4DB2-BD59-A6C34878D82A}">
+                    <a16:rowId xmlns:a16="http://schemas.microsoft.com/office/drawing/2014/main" val="10002"/>
+                  </a:ext>
+                </a:extLst>
+              </a:tr>
+              <a:tr h="320000">
+                <a:tc>
+                  <a:txBody>
+                    <a:bodyPr/>
+                    <a:lstStyle/>
+                    <a:p>
+                      <a:pPr algn="l"/>
+                      <a:r>
+                        <a:rPr lang="en-US" sz="1000" dirty="0">
+                          <a:solidFill>
+                            <a:srgbClr val="8B8FA8"/>
+                          </a:solidFill>
+                          <a:latin typeface="Calibri"/>
+                        </a:rPr>
+                        <a:t>GPT-4o mini</a:t>
+                      </a:r>
+                    </a:p>
+                  </a:txBody>
+                  <a:tcPr>
+                    <a:solidFill>
+                      <a:srgbClr val="12132A"/>
+                    </a:solidFill>
+                  </a:tcPr>
+                </a:tc>
+                <a:tc>
+                  <a:txBody>
+                    <a:bodyPr/>
+                    <a:lstStyle/>
+                    <a:p>
+                      <a:pPr algn="l"/>
+                      <a:r>
+                        <a:rPr lang="en-US" sz="1000" dirty="0">
+                          <a:solidFill>
+                            <a:srgbClr val="8B8FA8"/>
+                          </a:solidFill>
+                          <a:latin typeface="Calibri"/>
+                        </a:rPr>
+                        <a:t>~100–150</a:t>
+                      </a:r>
+                    </a:p>
+                  </a:txBody>
+                  <a:tcPr>
+                    <a:solidFill>
+                      <a:srgbClr val="12132A"/>
+                    </a:solidFill>
+                  </a:tcPr>
+                </a:tc>
+                <a:tc>
+                  <a:txBody>
+                    <a:bodyPr/>
+                    <a:lstStyle/>
+                    <a:p>
+                      <a:pPr algn="l"/>
+                      <a:r>
+                        <a:rPr lang="en-US" sz="1000" dirty="0">
+                          <a:solidFill>
+                            <a:srgbClr val="8B8FA8"/>
+                          </a:solidFill>
+                          <a:latin typeface="Calibri"/>
+                        </a:rPr>
+                        <a:t>1.5–2.5s</a:t>
+                      </a:r>
+                    </a:p>
+                  </a:txBody>
+                  <a:tcPr>
+                    <a:solidFill>
+                      <a:srgbClr val="12132A"/>
+                    </a:solidFill>
+                  </a:tcPr>
+                </a:tc>
+                <a:extLst>
+                  <a:ext uri="{0D108BD9-81ED-4DB2-BD59-A6C34878D82A}">
+                    <a16:rowId xmlns:a16="http://schemas.microsoft.com/office/drawing/2014/main" val="10003"/>
+                  </a:ext>
+                </a:extLst>
+              </a:tr>
+              <a:tr h="320000">
+                <a:tc>
+                  <a:txBody>
+                    <a:bodyPr/>
+                    <a:lstStyle/>
+                    <a:p>
+                      <a:pPr algn="l"/>
+                      <a:r>
+                        <a:rPr lang="en-US" sz="1000" dirty="0">
+                          <a:solidFill>
+                            <a:srgbClr val="8B8FA8"/>
+                          </a:solidFill>
+                          <a:latin typeface="Calibri"/>
+                        </a:rPr>
+                        <a:t>Claude 3.5 Haiku</a:t>
+                      </a:r>
+                    </a:p>
+                  </a:txBody>
+                  <a:tcPr>
+                    <a:solidFill>
+                      <a:srgbClr val="16172A"/>
+                    </a:solidFill>
+                  </a:tcPr>
+                </a:tc>
+                <a:tc>
+                  <a:txBody>
+                    <a:bodyPr/>
+                    <a:lstStyle/>
+                    <a:p>
+                      <a:pPr algn="l"/>
+                      <a:r>
+                        <a:rPr lang="en-US" sz="1000" dirty="0">
+                          <a:solidFill>
+                            <a:srgbClr val="8B8FA8"/>
+                          </a:solidFill>
+                          <a:latin typeface="Calibri"/>
+                        </a:rPr>
+                        <a:t>~100–150</a:t>
+                      </a:r>
+                    </a:p>
+                  </a:txBody>
+                  <a:tcPr>
+                    <a:solidFill>
+                      <a:srgbClr val="16172A"/>
+                    </a:solidFill>
+                  </a:tcPr>
+                </a:tc>
+                <a:tc>
+                  <a:txBody>
+                    <a:bodyPr/>
+                    <a:lstStyle/>
+                    <a:p>
+                      <a:pPr algn="l"/>
+                      <a:r>
+                        <a:rPr lang="en-US" sz="1000" dirty="0">
+                          <a:solidFill>
+                            <a:srgbClr val="8B8FA8"/>
+                          </a:solidFill>
+                          <a:latin typeface="Calibri"/>
+                        </a:rPr>
+                        <a:t>1.5–2.5s</a:t>
+                      </a:r>
+                    </a:p>
+                  </a:txBody>
+                  <a:tcPr>
+                    <a:solidFill>
+                      <a:srgbClr val="16172A"/>
+                    </a:solidFill>
+                  </a:tcPr>
+                </a:tc>
+                <a:extLst>
+                  <a:ext uri="{0D108BD9-81ED-4DB2-BD59-A6C34878D82A}">
+                    <a16:rowId xmlns:a16="http://schemas.microsoft.com/office/drawing/2014/main" val="10004"/>
+                  </a:ext>
+                </a:extLst>
+              </a:tr>
+              <a:tr h="320000">
+                <a:tc>
+                  <a:txBody>
+                    <a:bodyPr/>
+                    <a:lstStyle/>
+                    <a:p>
+                      <a:pPr algn="l"/>
+                      <a:r>
+                        <a:rPr lang="en-US" sz="1000" dirty="0">
+                          <a:solidFill>
+                            <a:srgbClr val="8B8FA8"/>
+                          </a:solidFill>
+                          <a:latin typeface="Calibri"/>
+                        </a:rPr>
+                        <a:t>GPT-4o (limited free)</a:t>
+                      </a:r>
+                    </a:p>
+                  </a:txBody>
+                  <a:tcPr>
+                    <a:solidFill>
+                      <a:srgbClr val="12132A"/>
+                    </a:solidFill>
+                  </a:tcPr>
+                </a:tc>
+                <a:tc>
+                  <a:txBody>
+                    <a:bodyPr/>
+                    <a:lstStyle/>
+                    <a:p>
+                      <a:pPr algn="l"/>
+                      <a:r>
+                        <a:rPr lang="en-US" sz="1000" dirty="0">
+                          <a:solidFill>
+                            <a:srgbClr val="8B8FA8"/>
+                          </a:solidFill>
+                          <a:latin typeface="Calibri"/>
+                        </a:rPr>
+                        <a:t>~80–100</a:t>
+                      </a:r>
+                    </a:p>
+                  </a:txBody>
+                  <a:tcPr>
+                    <a:solidFill>
+                      <a:srgbClr val="12132A"/>
+                    </a:solidFill>
+                  </a:tcPr>
+                </a:tc>
+                <a:tc>
+                  <a:txBody>
+                    <a:bodyPr/>
+                    <a:lstStyle/>
+                    <a:p>
+                      <a:pPr algn="l"/>
+                      <a:r>
+                        <a:rPr lang="en-US" sz="1000" dirty="0">
+                          <a:solidFill>
+                            <a:srgbClr val="8B8FA8"/>
+                          </a:solidFill>
+                          <a:latin typeface="Calibri"/>
+                        </a:rPr>
+                        <a:t>2.0–3.0s</a:t>
+                      </a:r>
+                    </a:p>
+                  </a:txBody>
+                  <a:tcPr>
+                    <a:solidFill>
+                      <a:srgbClr val="12132A"/>
+                    </a:solidFill>
+                  </a:tcPr>
+                </a:tc>
+                <a:extLst>
+                  <a:ext uri="{0D108BD9-81ED-4DB2-BD59-A6C34878D82A}">
+                    <a16:rowId xmlns:a16="http://schemas.microsoft.com/office/drawing/2014/main" val="10005"/>
+                  </a:ext>
+                </a:extLst>
+              </a:tr>
+            </a:tbl>
+          </a:graphicData>
+        </a:graphic>
+      </p:graphicFrame>
+      <p:sp>
+        <p:nvSpPr>
+          <p:cNvPr id="16" name="RCard"/>
+          <p:cNvSpPr/>
+          <p:nvPr/>
+        </p:nvSpPr>
+        <p:spPr>
+          <a:xfrm>
+            <a:off x="4754880" y="762000"/>
+            <a:ext cx="3977640" cy="2286000"/>
+          </a:xfrm>
+          <a:prstGeom prst="rect">
+            <a:avLst/>
+          </a:prstGeom>
+          <a:solidFill>
+            <a:srgbClr val="16172A"/>
+          </a:solidFill>
+          <a:ln w="9525">
+            <a:solidFill>
+              <a:srgbClr val="2A2B40"/>
+            </a:solidFill>
+          </a:ln>
+        </p:spPr>
+        <p:txBody>
+          <a:bodyPr/>
+          <a:lstStyle/>
+          <a:p>
+            <a:endParaRPr lang="en-US"/>
+          </a:p>
+        </p:txBody>
+      </p:sp>
+      <p:sp>
+        <p:nvSpPr>
+          <p:cNvPr id="17" name="RHdr"/>
+          <p:cNvSpPr txBox="1"/>
+          <p:nvPr/>
+        </p:nvSpPr>
+        <p:spPr>
+          <a:xfrm>
+            <a:off x="4800600" y="776000"/>
+            <a:ext cx="3886200" cy="280000"/>
+          </a:xfrm>
+          <a:prstGeom prst="rect">
+            <a:avLst/>
+          </a:prstGeom>
+          <a:noFill/>
+          <a:ln>
+            <a:noFill/>
+          </a:ln>
+        </p:spPr>
+        <p:txBody>
+          <a:bodyPr wrap="square" anchor="t">
+            <a:noAutofit/>
+          </a:bodyPr>
+          <a:lstStyle/>
+          <a:p>
+            <a:pPr algn="l">
+              <a:spcAft>
+                <a:spcPts val="100"/>
+              </a:spcAft>
+            </a:pPr>
+            <a:r>
+              <a:rPr lang="en-US" sz="1600" b="1" dirty="0">
+                <a:solidFill>
+                  <a:srgbClr val="A78BFA"/>
+                </a:solidFill>
+                <a:latin typeface="Calibri"/>
+              </a:rPr>
+              <a:t>🖥  Full Workflow Speed (realistic)</a:t>
+            </a:r>
+          </a:p>
+        </p:txBody>
+      </p:sp>
+      <p:graphicFrame>
+        <p:nvGraphicFramePr>
+          <p:cNvPr id="18" name="WFTable"/>
+          <p:cNvGraphicFramePr>
+            <a:graphicFrameLocks noGrp="1"/>
+          </p:cNvGraphicFramePr>
+          <p:nvPr/>
+        </p:nvGraphicFramePr>
+        <p:xfrm>
+          <a:off x="4800600" y="1080000"/>
+          <a:ext cx="3886200" cy="1950000"/>
+        </p:xfrm>
+        <a:graphic>
+          <a:graphicData uri="http://schemas.openxmlformats.org/drawingml/2006/table">
+            <a:tbl>
+              <a:tblPr/>
+              <a:tblGrid>
+                <a:gridCol w="2286200">
+                  <a:extLst>
+                    <a:ext uri="{9D8B030D-6E8A-4147-A177-3AD203B41FA5}">
+                      <a16:colId xmlns:a16="http://schemas.microsoft.com/office/drawing/2014/main" val="20000"/>
+                    </a:ext>
+                  </a:extLst>
+                </a:gridCol>
+                <a:gridCol w="1600000">
+                  <a:extLst>
+                    <a:ext uri="{9D8B030D-6E8A-4147-A177-3AD203B41FA5}">
+                      <a16:colId xmlns:a16="http://schemas.microsoft.com/office/drawing/2014/main" val="20001"/>
+                    </a:ext>
+                  </a:extLst>
+                </a:gridCol>
+              </a:tblGrid>
+              <a:tr h="320000">
+                <a:tc>
+                  <a:txBody>
+                    <a:bodyPr/>
+                    <a:lstStyle/>
+                    <a:p>
+                      <a:pPr algn="l"/>
+                      <a:r>
+                        <a:rPr lang="en-US" sz="1100" b="1" dirty="0">
+                          <a:solidFill>
+                            <a:srgbClr val="EEF2FF"/>
+                          </a:solidFill>
+                          <a:latin typeface="Calibri"/>
+                        </a:rPr>
+                        <a:t>Tool</a:t>
+                      </a:r>
+                    </a:p>
+                  </a:txBody>
+                  <a:tcPr>
+                    <a:solidFill>
+                      <a:srgbClr val="1E1F35"/>
+                    </a:solidFill>
+                  </a:tcPr>
+                </a:tc>
+                <a:tc>
+                  <a:txBody>
+                    <a:bodyPr/>
+                    <a:lstStyle/>
+                    <a:p>
+                      <a:pPr algn="l"/>
+                      <a:r>
+                        <a:rPr lang="en-US" sz="1100" b="1" dirty="0">
+                          <a:solidFill>
+                            <a:srgbClr val="EEF2FF"/>
+                          </a:solidFill>
+                          <a:latin typeface="Calibri"/>
+                        </a:rPr>
+                        <a:t>Total Time</a:t>
+                      </a:r>
+                    </a:p>
+                  </a:txBody>
+                  <a:tcPr>
+                    <a:solidFill>
+                      <a:srgbClr val="1E1F35"/>
+                    </a:solidFill>
+                  </a:tcPr>
+                </a:tc>
+                <a:extLst>
+                  <a:ext uri="{0D108BD9-81ED-4DB2-BD59-A6C34878D82A}">
+                    <a16:rowId xmlns:a16="http://schemas.microsoft.com/office/drawing/2014/main" val="10000"/>
+                  </a:ext>
+                </a:extLst>
+              </a:tr>
+              <a:tr h="430000">
+                <a:tc>
+                  <a:txBody>
+                    <a:bodyPr/>
+                    <a:lstStyle/>
+                    <a:p>
+                      <a:pPr algn="l"/>
+                      <a:r>
+                        <a:rPr lang="en-US" sz="1050" b="1" dirty="0">
+                          <a:solidFill>
+                            <a:srgbClr val="A78BFA"/>
+                          </a:solidFill>
+                          <a:latin typeface="Calibri"/>
+                        </a:rPr>
+                        <a:t>BEBO</a:t>
+                      </a:r>
+                    </a:p>
+                  </a:txBody>
+                  <a:tcPr>
+                    <a:solidFill>
+                      <a:srgbClr val="2D1B69"/>
+                    </a:solidFill>
+                  </a:tcPr>
+                </a:tc>
+                <a:tc>
+                  <a:txBody>
+                    <a:bodyPr/>
+                    <a:lstStyle/>
+                    <a:p>
+                      <a:pPr algn="l"/>
+                      <a:r>
+                        <a:rPr lang="en-US" sz="1050" b="1" dirty="0">
+                          <a:solidFill>
+                            <a:srgbClr val="6EE7B7"/>
+                          </a:solidFill>
+                          <a:latin typeface="Calibri"/>
+                        </a:rPr>
+                        <a:t>~3–4 sec ★</a:t>
+                      </a:r>
+                    </a:p>
+                  </a:txBody>
+                  <a:tcPr>
+                    <a:solidFill>
+                      <a:srgbClr val="2D1B69"/>
+                    </a:solidFill>
+                  </a:tcPr>
+                </a:tc>
+                <a:extLst>
+                  <a:ext uri="{0D108BD9-81ED-4DB2-BD59-A6C34878D82A}">
+                    <a16:rowId xmlns:a16="http://schemas.microsoft.com/office/drawing/2014/main" val="10001"/>
+                  </a:ext>
+                </a:extLst>
+              </a:tr>
+              <a:tr h="400000">
+                <a:tc>
+                  <a:txBody>
+                    <a:bodyPr/>
+                    <a:lstStyle/>
+                    <a:p>
+                      <a:pPr algn="l"/>
+                      <a:r>
+                        <a:rPr lang="en-US" sz="1000" dirty="0">
+                          <a:solidFill>
+                            <a:srgbClr val="8B8FA8"/>
+                          </a:solidFill>
+                          <a:latin typeface="Calibri"/>
+                        </a:rPr>
+                        <a:t>Gemini 2.0 Flash</a:t>
+                      </a:r>
+                    </a:p>
+                  </a:txBody>
+                  <a:tcPr>
+                    <a:solidFill>
+                      <a:srgbClr val="16172A"/>
+                    </a:solidFill>
+                  </a:tcPr>
+                </a:tc>
+                <a:tc>
+                  <a:txBody>
+                    <a:bodyPr/>
+                    <a:lstStyle/>
+                    <a:p>
+                      <a:pPr algn="l"/>
+                      <a:r>
+                        <a:rPr lang="en-US" sz="1000" dirty="0">
+                          <a:solidFill>
+                            <a:srgbClr val="8B8FA8"/>
+                          </a:solidFill>
+                          <a:latin typeface="Calibri"/>
+                        </a:rPr>
+                        <a:t>~10–13 sec</a:t>
+                      </a:r>
+                    </a:p>
+                  </a:txBody>
+                  <a:tcPr>
+                    <a:solidFill>
+                      <a:srgbClr val="16172A"/>
+                    </a:solidFill>
+                  </a:tcPr>
+                </a:tc>
+                <a:extLst>
+                  <a:ext uri="{0D108BD9-81ED-4DB2-BD59-A6C34878D82A}">
+                    <a16:rowId xmlns:a16="http://schemas.microsoft.com/office/drawing/2014/main" val="10002"/>
+                  </a:ext>
+                </a:extLst>
+              </a:tr>
+              <a:tr h="400000">
+                <a:tc>
+                  <a:txBody>
+                    <a:bodyPr/>
+                    <a:lstStyle/>
+                    <a:p>
+                      <a:pPr algn="l"/>
+                      <a:r>
+                        <a:rPr lang="en-US" sz="1000" dirty="0">
+                          <a:solidFill>
+                            <a:srgbClr val="8B8FA8"/>
+                          </a:solidFill>
+                          <a:latin typeface="Calibri"/>
+                        </a:rPr>
+                        <a:t>ChatGPT (GPT-4o mini)</a:t>
+                      </a:r>
+                    </a:p>
+                  </a:txBody>
+                  <a:tcPr>
+                    <a:solidFill>
+                      <a:srgbClr val="12132A"/>
+                    </a:solidFill>
+                  </a:tcPr>
+                </a:tc>
+                <a:tc>
+                  <a:txBody>
+                    <a:bodyPr/>
+                    <a:lstStyle/>
+                    <a:p>
+                      <a:pPr algn="l"/>
+                      <a:r>
+                        <a:rPr lang="en-US" sz="1000" dirty="0">
+                          <a:solidFill>
+                            <a:srgbClr val="8B8FA8"/>
+                          </a:solidFill>
+                          <a:latin typeface="Calibri"/>
+                        </a:rPr>
+                        <a:t>~11–14 sec</a:t>
+                      </a:r>
+                    </a:p>
+                  </a:txBody>
+                  <a:tcPr>
+                    <a:solidFill>
+                      <a:srgbClr val="12132A"/>
+                    </a:solidFill>
+                  </a:tcPr>
+                </a:tc>
+                <a:extLst>
+                  <a:ext uri="{0D108BD9-81ED-4DB2-BD59-A6C34878D82A}">
+                    <a16:rowId xmlns:a16="http://schemas.microsoft.com/office/drawing/2014/main" val="10003"/>
+                  </a:ext>
+                </a:extLst>
+              </a:tr>
+              <a:tr h="400000">
+                <a:tc>
+                  <a:txBody>
+                    <a:bodyPr/>
+                    <a:lstStyle/>
+                    <a:p>
+                      <a:pPr algn="l"/>
+                      <a:r>
+                        <a:rPr lang="en-US" sz="1000" dirty="0">
+                          <a:solidFill>
+                            <a:srgbClr val="8B8FA8"/>
+                          </a:solidFill>
+                          <a:latin typeface="Calibri"/>
+                        </a:rPr>
+                        <a:t>Claude (browser)</a:t>
+                      </a:r>
+                    </a:p>
+                  </a:txBody>
+                  <a:tcPr>
+                    <a:solidFill>
+                      <a:srgbClr val="16172A"/>
+                    </a:solidFill>
+                  </a:tcPr>
+                </a:tc>
+                <a:tc>
+                  <a:txBody>
+                    <a:bodyPr/>
+                    <a:lstStyle/>
+                    <a:p>
+                      <a:pPr algn="l"/>
+                      <a:r>
+                        <a:rPr lang="en-US" sz="1000" dirty="0">
+                          <a:solidFill>
+                            <a:srgbClr val="8B8FA8"/>
+                          </a:solidFill>
+                          <a:latin typeface="Calibri"/>
+                        </a:rPr>
+                        <a:t>~12–15 sec</a:t>
+                      </a:r>
+                    </a:p>
+                  </a:txBody>
+                  <a:tcPr>
+                    <a:solidFill>
+                      <a:srgbClr val="16172A"/>
+                    </a:solidFill>
+                  </a:tcPr>
+                </a:tc>
+                <a:extLst>
+                  <a:ext uri="{0D108BD9-81ED-4DB2-BD59-A6C34878D82A}">
+                    <a16:rowId xmlns:a16="http://schemas.microsoft.com/office/drawing/2014/main" val="10004"/>
+                  </a:ext>
+                </a:extLst>
+              </a:tr>
+            </a:tbl>
+          </a:graphicData>
+        </a:graphic>
+      </p:graphicFrame>
+      <p:sp>
+        <p:nvSpPr>
+          <p:cNvPr id="19" name="VL_bg"/>
+          <p:cNvSpPr/>
+          <p:nvPr/>
+        </p:nvSpPr>
+        <p:spPr>
+          <a:xfrm>
+            <a:off x="411480" y="3160000"/>
+            <a:ext cx="3977640" cy="1560000"/>
+          </a:xfrm>
+          <a:prstGeom prst="rect">
+            <a:avLst/>
+          </a:prstGeom>
+          <a:solidFill>
+            <a:srgbClr val="065F46"/>
+          </a:solidFill>
+          <a:ln w="9525">
+            <a:solidFill>
+              <a:srgbClr val="065F46"/>
+            </a:solidFill>
+          </a:ln>
+        </p:spPr>
+        <p:txBody>
+          <a:bodyPr/>
+          <a:lstStyle/>
+          <a:p>
+            <a:endParaRPr lang="en-US"/>
+          </a:p>
+        </p:txBody>
+      </p:sp>
+      <p:sp>
+        <p:nvSpPr>
+          <p:cNvPr id="20" name="VL"/>
+          <p:cNvSpPr txBox="1"/>
+          <p:nvPr/>
+        </p:nvSpPr>
+        <p:spPr>
+          <a:xfrm>
+            <a:off x="548640" y="3274300"/>
+            <a:ext cx="3703320" cy="1331400"/>
+          </a:xfrm>
+          <a:prstGeom prst="rect">
+            <a:avLst/>
+          </a:prstGeom>
+          <a:noFill/>
+          <a:ln>
+            <a:noFill/>
+          </a:ln>
+        </p:spPr>
+        <p:txBody>
+          <a:bodyPr wrap="square" anchor="ctr">
+            <a:noAutofit/>
+          </a:bodyPr>
+          <a:lstStyle/>
+          <a:p>
+            <a:pPr algn="l">
+              <a:spcAft>
+                <a:spcPts val="100"/>
+              </a:spcAft>
+            </a:pPr>
+            <a:r>
+              <a:rPr lang="en-US" sz="1700" b="1" dirty="0">
+                <a:solidFill>
+                  <a:srgbClr val="6EE7B7"/>
+                </a:solidFill>
+                <a:latin typeface="Calibri"/>
+              </a:rPr>
+              <a:t>✅  BEBO Wins on Speed</a:t>
+            </a:r>
+          </a:p>
+          <a:p>
+            <a:pPr algn="l">
+              <a:spcAft>
+                <a:spcPts val="100"/>
+              </a:spcAft>
+            </a:pPr>
+            <a:r>
+              <a:rPr lang="en-US" sz="1200" dirty="0">
+                <a:solidFill>
+                  <a:srgbClr val="EEF2FF"/>
+                </a:solidFill>
+                <a:latin typeface="Calibri"/>
+              </a:rPr>
+              <a:t>Groq LPUs — no GPU can match it.</a:t>
+            </a:r>
+          </a:p>
+          <a:p>
+            <a:pPr algn="l">
+              <a:spcAft>
+                <a:spcPts val="100"/>
+              </a:spcAft>
+            </a:pPr>
+            <a:r>
+              <a:rPr lang="en-US" sz="1200" dirty="0">
+                <a:solidFill>
+                  <a:srgbClr val="EEF2FF"/>
+                </a:solidFill>
+                <a:latin typeface="Calibri"/>
+              </a:rPr>
+              <a:t>Gemini 2.0 Flash is closing the gap but</a:t>
+            </a:r>
+          </a:p>
+          <a:p>
+            <a:pPr algn="l">
+              <a:spcAft>
+                <a:spcPts val="100"/>
+              </a:spcAft>
+            </a:pPr>
+            <a:r>
+              <a:rPr lang="en-US" sz="1200" dirty="0">
+                <a:solidFill>
+                  <a:srgbClr val="EEF2FF"/>
+                </a:solidFill>
+                <a:latin typeface="Calibri"/>
+              </a:rPr>
+              <a:t>BEBO still 3–5× faster end-to-end.</a:t>
+            </a:r>
+          </a:p>
+        </p:txBody>
+      </p:sp>
+      <p:sp>
+        <p:nvSpPr>
+          <p:cNvPr id="21" name="VR_bg"/>
+          <p:cNvSpPr/>
+          <p:nvPr/>
+        </p:nvSpPr>
+        <p:spPr>
+          <a:xfrm>
+            <a:off x="4754880" y="3160000"/>
+            <a:ext cx="3977640" cy="1560000"/>
+          </a:xfrm>
+          <a:prstGeom prst="rect">
+            <a:avLst/>
+          </a:prstGeom>
+          <a:solidFill>
+            <a:srgbClr val="1F2937"/>
+          </a:solidFill>
+          <a:ln w="9525">
+            <a:solidFill>
+              <a:srgbClr val="374151"/>
+            </a:solidFill>
+          </a:ln>
+        </p:spPr>
+        <p:txBody>
+          <a:bodyPr/>
+          <a:lstStyle/>
+          <a:p>
+            <a:endParaRPr lang="en-US"/>
+          </a:p>
+        </p:txBody>
+      </p:sp>
+      <p:sp>
+        <p:nvSpPr>
+          <p:cNvPr id="22" name="VR"/>
+          <p:cNvSpPr txBox="1"/>
+          <p:nvPr/>
+        </p:nvSpPr>
+        <p:spPr>
+          <a:xfrm>
+            <a:off x="4892040" y="3274300"/>
+            <a:ext cx="3703320" cy="1331400"/>
+          </a:xfrm>
+          <a:prstGeom prst="rect">
+            <a:avLst/>
+          </a:prstGeom>
+          <a:noFill/>
+          <a:ln>
+            <a:noFill/>
+          </a:ln>
+        </p:spPr>
+        <p:txBody>
+          <a:bodyPr wrap="square" anchor="ctr">
+            <a:noAutofit/>
+          </a:bodyPr>
+          <a:lstStyle/>
+          <a:p>
+            <a:pPr algn="l">
+              <a:spcAft>
+                <a:spcPts val="100"/>
+              </a:spcAft>
+            </a:pPr>
+            <a:r>
+              <a:rPr lang="en-US" sz="1700" b="1" dirty="0">
+                <a:solidFill>
+                  <a:srgbClr val="9CA3AF"/>
+                </a:solidFill>
+                <a:latin typeface="Calibri"/>
+              </a:rPr>
+              <a:t>❌  Others Win</a:t>
+            </a:r>
+          </a:p>
+          <a:p>
+            <a:pPr algn="l">
+              <a:spcAft>
+                <a:spcPts val="100"/>
+              </a:spcAft>
+            </a:pPr>
+            <a:r>
+              <a:rPr lang="en-US" sz="1200" dirty="0">
+                <a:solidFill>
+                  <a:srgbClr val="EEF2FF"/>
+                </a:solidFill>
+                <a:latin typeface="Calibri"/>
+              </a:rPr>
+              <a:t>Complex reasoning, coding,</a:t>
+            </a:r>
+          </a:p>
+          <a:p>
+            <a:pPr algn="l">
+              <a:spcAft>
+                <a:spcPts val="100"/>
+              </a:spcAft>
+            </a:pPr>
+            <a:r>
+              <a:rPr lang="en-US" sz="1200" dirty="0">
+                <a:solidFill>
+                  <a:srgbClr val="EEF2FF"/>
+                </a:solidFill>
+                <a:latin typeface="Calibri"/>
+              </a:rPr>
+              <a:t>image understanding, memory,</a:t>
+            </a:r>
+          </a:p>
+          <a:p>
+            <a:pPr algn="l">
+              <a:spcAft>
+                <a:spcPts val="100"/>
+              </a:spcAft>
+            </a:pPr>
+            <a:r>
+              <a:rPr lang="en-US" sz="1200" dirty="0">
+                <a:solidFill>
+                  <a:srgbClr val="EEF2FF"/>
+                </a:solidFill>
+                <a:latin typeface="Calibri"/>
+              </a:rPr>
+              <a:t>long documents, real-time data.</a:t>
+            </a:r>
+          </a:p>
+        </p:txBody>
+      </p:sp>
+      <p:sp>
+        <p:nvSpPr>
+          <p:cNvPr id="23" name="Source"/>
+          <p:cNvSpPr txBox="1"/>
+          <p:nvPr/>
+        </p:nvSpPr>
+        <p:spPr>
+          <a:xfrm>
+            <a:off x="457200" y="4890000"/>
+            <a:ext cx="8229600" cy="228600"/>
+          </a:xfrm>
+          <a:prstGeom prst="rect">
+            <a:avLst/>
+          </a:prstGeom>
+          <a:noFill/>
+          <a:ln>
+            <a:noFill/>
+          </a:ln>
+        </p:spPr>
+        <p:txBody>
+          <a:bodyPr wrap="square" anchor="t">
+            <a:noAutofit/>
+          </a:bodyPr>
+          <a:lstStyle/>
+          <a:p>
+            <a:pPr algn="l">
+              <a:spcAft>
+                <a:spcPts val="100"/>
+              </a:spcAft>
+            </a:pPr>
+            <a:r>
+              <a:rPr lang="en-US" sz="900" dirty="0">
+                <a:solidFill>
+                  <a:srgbClr val="8B8FA8"/>
+                </a:solidFill>
+                <a:latin typeface="Calibri"/>
+              </a:rPr>
+              <a:t>Source: Groq published benchmarks · measured workflow timing (browser already open)</a:t>
+            </a:r>
+          </a:p>
+        </p:txBody>
+      </p:sp>
+    </p:spTree>
+    <p:extLst>
+      <p:ext uri="{BB962C8B-B14F-4D97-AF65-F5344CB8AC3E}">
+        <p14:creationId xmlns:p14="http://schemas.microsoft.com/office/powerpoint/2010/main" val="3983155845"/>
+      </p:ext>
+    </p:extLst>
   </p:cSld>
   <p:clrMapOvr>
     <a:masterClrMapping/>
@@ -24589,4 +25931,26 @@
     </a:ext>
   </a:extLst>
 </a:theme>
+</file>
+
+<file path=ppt/webextensions/taskpanes.xml><?xml version="1.0" encoding="utf-8"?>
+<wetp:taskpanes xmlns:wetp="http://schemas.microsoft.com/office/webextensions/taskpanes/2010/11">
+  <wetp:taskpane dockstate="right" visibility="0" width="438" row="0">
+    <wetp:webextensionref xmlns:r="http://schemas.openxmlformats.org/officeDocument/2006/relationships" r:id="rId1"/>
+  </wetp:taskpane>
+</wetp:taskpanes>
+</file>
+
+<file path=ppt/webextensions/webextension1.xml><?xml version="1.0" encoding="utf-8"?>
+<we:webextension xmlns:we="http://schemas.microsoft.com/office/webextensions/webextension/2010/11" id="{DAF0E180-290A-445B-B9EF-06B6EE56E9FA}">
+  <we:reference id="wa200010001" version="1.0.0.1" store="en-GB" storeType="OMEX"/>
+  <we:alternateReferences>
+    <we:reference id="wa200010001" version="1.0.0.1" store="" storeType="OMEX"/>
+  </we:alternateReferences>
+  <we:properties>
+    <we:property name="claude.fileId" value="&quot;ba0ea580-21ff-4c13-ac73-d8941c0a1171&quot;"/>
+  </we:properties>
+  <we:bindings/>
+  <we:snapshot xmlns:r="http://schemas.openxmlformats.org/officeDocument/2006/relationships"/>
+</we:webextension>
 </file>
</xml_diff>

<commit_message>
BEBO 2.0 follow-up: site refresh, carousel 2.0, authentic deck screenshots
- docs site: What's New in 2.0 section, FAQ additions (voice input,
  remappable shortcuts, auto-start fix), real 2.0 panel screenshot
- carousel: 2.0 badge, pruned shipped roadmap items, real panel shot,
  author card contrast fix, label repositioned below panel
- pitch deck: Llama->GPT-OSS truth sweep (24 fixes), replaced drawn
  mockups with real captures (desktop pet, dark panel, light panel
  with live AI result), roadmap updated for shipped 2.0 features
- add MIT LICENSE + GitHub Actions build workflow (SignPath prep)

Co-Authored-By: Claude Fable 5 <noreply@anthropic.com>
</commit_message>
<xml_diff>
--- a/BEBO-Pitch-Deck.pptx
+++ b/BEBO-Pitch-Deck.pptx
@@ -2443,7 +2443,7 @@
                 <a:ea typeface="Calibri" pitchFamily="34" charset="-122"/>
                 <a:cs typeface="Calibri" pitchFamily="34" charset="-120"/>
               </a:rPr>
-              <a:t>Powered by  Llama 3.3 70B  ×  Groq  ×  Electron</a:t>
+              <a:t>Powered by  GPT-OSS 120B  ×  Groq  ×  Electron</a:t>
             </a:r>
             <a:endParaRPr lang="en-US" sz="1000" dirty="0"/>
           </a:p>
@@ -4814,30 +4814,6 @@
           </a:p>
         </p:txBody>
       </p:sp>
-      <p:pic>
-        <p:nvPicPr>
-          <p:cNvPr id="6" name="Image 0" descr="C:\Users\admin\OneDrive - Lal Bahadur Shastri Institute of Management\Documents\BEBO the PET\docs\screenshots\bebo-pet-on-desktop.png"/>
-          <p:cNvPicPr>
-            <a:picLocks noChangeAspect="1"/>
-          </p:cNvPicPr>
-          <p:nvPr/>
-        </p:nvPicPr>
-        <p:blipFill>
-          <a:blip r:embed="rId3"/>
-          <a:stretch>
-            <a:fillRect/>
-          </a:stretch>
-        </p:blipFill>
-        <p:spPr>
-          <a:xfrm>
-            <a:off x="329184" y="1024128"/>
-            <a:ext cx="2578608" cy="3154680"/>
-          </a:xfrm>
-          <a:prstGeom prst="rect">
-            <a:avLst/>
-          </a:prstGeom>
-        </p:spPr>
-      </p:pic>
       <p:sp>
         <p:nvSpPr>
           <p:cNvPr id="7" name="Text 4"/>
@@ -4911,31 +4887,6 @@
           </a:p>
         </p:txBody>
       </p:sp>
-      <p:pic>
-        <p:nvPicPr>
-          <p:cNvPr id="9" name="Image 1" descr="C:\Users\admin\OneDrive - Lal Bahadur Shastri Institute of Management\Documents\BEBO the PET\docs\screenshots\bebo-panel-open.png"/>
-          <p:cNvPicPr>
-            <a:picLocks noChangeAspect="1"/>
-          </p:cNvPicPr>
-          <p:nvPr/>
-        </p:nvPicPr>
-        <p:blipFill>
-          <a:blip r:embed="rId4"/>
-          <a:srcRect l="35663"/>
-          <a:stretch>
-            <a:fillRect/>
-          </a:stretch>
-        </p:blipFill>
-        <p:spPr>
-          <a:xfrm>
-            <a:off x="3145536" y="1024128"/>
-            <a:ext cx="2615183" cy="3154680"/>
-          </a:xfrm>
-          <a:prstGeom prst="rect">
-            <a:avLst/>
-          </a:prstGeom>
-        </p:spPr>
-      </p:pic>
       <p:sp>
         <p:nvSpPr>
           <p:cNvPr id="10" name="Text 6"/>
@@ -5009,108 +4960,156 @@
           </a:p>
         </p:txBody>
       </p:sp>
+      <p:sp>
+        <p:nvSpPr>
+          <p:cNvPr id="13" name="Text 8"/>
+          <p:cNvSpPr/>
+          <p:nvPr/>
+        </p:nvSpPr>
+        <p:spPr>
+          <a:xfrm>
+            <a:off x="5998464" y="4315968"/>
+            <a:ext cx="2651760" cy="438912"/>
+          </a:xfrm>
+          <a:prstGeom prst="rect">
+            <a:avLst/>
+          </a:prstGeom>
+          <a:noFill/>
+          <a:ln/>
+        </p:spPr>
+        <p:txBody>
+          <a:bodyPr wrap="square" lIns="0" tIns="0" rIns="0" bIns="0" rtlCol="0" anchor="ctr"/>
+          <a:lstStyle/>
+          <a:p>
+            <a:pPr marL="0" indent="0" algn="ctr">
+              <a:buNone/>
+            </a:pPr>
+            <a:r>
+              <a:rPr lang="en-US" sz="1000" dirty="0">
+                <a:solidFill>
+                  <a:srgbClr val="A78BFA"/>
+                </a:solidFill>
+                <a:latin typeface="Calibri" pitchFamily="34" charset="0"/>
+                <a:ea typeface="Calibri" pitchFamily="34" charset="-122"/>
+                <a:cs typeface="Calibri" pitchFamily="34" charset="-120"/>
+              </a:rPr>
+              <a:t>Editable output • One-click Copy • Under 2s</a:t>
+            </a:r>
+            <a:endParaRPr lang="en-US" sz="1000" dirty="0"/>
+          </a:p>
+        </p:txBody>
+      </p:sp>
+      <p:sp>
+        <p:nvSpPr>
+          <p:cNvPr id="14" name="Text 9"/>
+          <p:cNvSpPr/>
+          <p:nvPr/>
+        </p:nvSpPr>
+        <p:spPr>
+          <a:xfrm>
+            <a:off x="347472" y="4800600"/>
+            <a:ext cx="8449056" cy="219456"/>
+          </a:xfrm>
+          <a:prstGeom prst="rect">
+            <a:avLst/>
+          </a:prstGeom>
+          <a:noFill/>
+          <a:ln/>
+        </p:spPr>
+        <p:txBody>
+          <a:bodyPr wrap="square" lIns="0" tIns="0" rIns="0" bIns="0" rtlCol="0" anchor="ctr"/>
+          <a:lstStyle/>
+          <a:p>
+            <a:pPr marL="0" indent="0" algn="ctr">
+              <a:buNone/>
+            </a:pPr>
+            <a:r>
+              <a:rPr lang="en-US" sz="1000" dirty="0">
+                <a:solidFill>
+                  <a:srgbClr val="94A3B8"/>
+                </a:solidFill>
+                <a:latin typeface="Calibri" pitchFamily="34" charset="0"/>
+                <a:ea typeface="Calibri" pitchFamily="34" charset="-122"/>
+                <a:cs typeface="Calibri" pitchFamily="34" charset="-120"/>
+              </a:rPr>
+              <a:t>Panel opens next to BEBO's position  •  Resizable  •  Editable output  •  One-click Copy</a:t>
+            </a:r>
+            <a:endParaRPr lang="en-US" sz="1000" dirty="0"/>
+          </a:p>
+        </p:txBody>
+      </p:sp>
       <p:pic>
         <p:nvPicPr>
-          <p:cNvPr id="12" name="Image 2" descr="C:\Users\admin\OneDrive - Lal Bahadur Shastri Institute of Management\Documents\BEBO the PET\docs\screenshots\bebo-ai-output.png"/>
+          <p:cNvPr id="15" name="Picture 14" descr="desktop-pet-clean.png"/>
           <p:cNvPicPr>
             <a:picLocks noChangeAspect="1"/>
           </p:cNvPicPr>
           <p:nvPr/>
         </p:nvPicPr>
         <p:blipFill>
-          <a:blip r:embed="rId5"/>
+          <a:blip r:embed="rId6"/>
           <a:stretch>
             <a:fillRect/>
           </a:stretch>
         </p:blipFill>
         <p:spPr>
           <a:xfrm>
-            <a:off x="6035040" y="1024128"/>
-            <a:ext cx="2578608" cy="3154680"/>
+            <a:off x="338328" y="1352840"/>
+            <a:ext cx="2560320" cy="2515544"/>
           </a:xfrm>
           <a:prstGeom prst="rect">
             <a:avLst/>
           </a:prstGeom>
         </p:spPr>
       </p:pic>
-      <p:sp>
-        <p:nvSpPr>
-          <p:cNvPr id="13" name="Text 8"/>
-          <p:cNvSpPr/>
-          <p:nvPr/>
-        </p:nvSpPr>
-        <p:spPr>
-          <a:xfrm>
-            <a:off x="5998464" y="4315968"/>
-            <a:ext cx="2651760" cy="438912"/>
-          </a:xfrm>
-          <a:prstGeom prst="rect">
-            <a:avLst/>
-          </a:prstGeom>
-          <a:noFill/>
-          <a:ln/>
-        </p:spPr>
-        <p:txBody>
-          <a:bodyPr wrap="square" lIns="0" tIns="0" rIns="0" bIns="0" rtlCol="0" anchor="ctr"/>
-          <a:lstStyle/>
-          <a:p>
-            <a:pPr marL="0" indent="0" algn="ctr">
-              <a:buNone/>
-            </a:pPr>
-            <a:r>
-              <a:rPr lang="en-US" sz="1000" dirty="0">
-                <a:solidFill>
-                  <a:srgbClr val="A78BFA"/>
-                </a:solidFill>
-                <a:latin typeface="Calibri" pitchFamily="34" charset="0"/>
-                <a:ea typeface="Calibri" pitchFamily="34" charset="-122"/>
-                <a:cs typeface="Calibri" pitchFamily="34" charset="-120"/>
-              </a:rPr>
-              <a:t>Editable output • One-click Copy • Under 2s</a:t>
-            </a:r>
-            <a:endParaRPr lang="en-US" sz="1000" dirty="0"/>
-          </a:p>
-        </p:txBody>
-      </p:sp>
-      <p:sp>
-        <p:nvSpPr>
-          <p:cNvPr id="14" name="Text 9"/>
-          <p:cNvSpPr/>
-          <p:nvPr/>
-        </p:nvSpPr>
-        <p:spPr>
-          <a:xfrm>
-            <a:off x="347472" y="4800600"/>
-            <a:ext cx="8449056" cy="219456"/>
-          </a:xfrm>
-          <a:prstGeom prst="rect">
-            <a:avLst/>
-          </a:prstGeom>
-          <a:noFill/>
-          <a:ln/>
-        </p:spPr>
-        <p:txBody>
-          <a:bodyPr wrap="square" lIns="0" tIns="0" rIns="0" bIns="0" rtlCol="0" anchor="ctr"/>
-          <a:lstStyle/>
-          <a:p>
-            <a:pPr marL="0" indent="0" algn="ctr">
-              <a:buNone/>
-            </a:pPr>
-            <a:r>
-              <a:rPr lang="en-US" sz="1000" dirty="0">
-                <a:solidFill>
-                  <a:srgbClr val="94A3B8"/>
-                </a:solidFill>
-                <a:latin typeface="Calibri" pitchFamily="34" charset="0"/>
-                <a:ea typeface="Calibri" pitchFamily="34" charset="-122"/>
-                <a:cs typeface="Calibri" pitchFamily="34" charset="-120"/>
-              </a:rPr>
-              <a:t>Panel opens next to BEBO's position  •  Resizable  •  Editable output  •  One-click Copy</a:t>
-            </a:r>
-            <a:endParaRPr lang="en-US" sz="1000" dirty="0"/>
-          </a:p>
-        </p:txBody>
-      </p:sp>
+      <p:pic>
+        <p:nvPicPr>
+          <p:cNvPr id="16" name="Picture 15" descr="shot2-dark.png"/>
+          <p:cNvPicPr>
+            <a:picLocks noChangeAspect="1"/>
+          </p:cNvPicPr>
+          <p:nvPr/>
+        </p:nvPicPr>
+        <p:blipFill>
+          <a:blip r:embed="rId7"/>
+          <a:stretch>
+            <a:fillRect/>
+          </a:stretch>
+        </p:blipFill>
+        <p:spPr>
+          <a:xfrm>
+            <a:off x="3498250" y="1033272"/>
+            <a:ext cx="1946331" cy="3154679"/>
+          </a:xfrm>
+          <a:prstGeom prst="rect">
+            <a:avLst/>
+          </a:prstGeom>
+        </p:spPr>
+      </p:pic>
+      <p:pic>
+        <p:nvPicPr>
+          <p:cNvPr id="17" name="Picture 16" descr="shot5-ai-result.png"/>
+          <p:cNvPicPr>
+            <a:picLocks noChangeAspect="1"/>
+          </p:cNvPicPr>
+          <p:nvPr/>
+        </p:nvPicPr>
+        <p:blipFill>
+          <a:blip r:embed="rId8"/>
+          <a:stretch>
+            <a:fillRect/>
+          </a:stretch>
+        </p:blipFill>
+        <p:spPr>
+          <a:xfrm>
+            <a:off x="6351178" y="1033272"/>
+            <a:ext cx="1946331" cy="3154679"/>
+          </a:xfrm>
+          <a:prstGeom prst="rect">
+            <a:avLst/>
+          </a:prstGeom>
+        </p:spPr>
+      </p:pic>
     </p:spTree>
   </p:cSld>
   <p:clrMapOvr>
@@ -6422,7 +6421,7 @@
                 <a:ea typeface="Calibri" pitchFamily="34" charset="-122"/>
                 <a:cs typeface="Calibri" pitchFamily="34" charset="-120"/>
               </a:rPr>
-              <a:t>🎙  Voice input — speak your prompt</a:t>
+              <a:t>🎙  Voice input — Win+H dictation</a:t>
             </a:r>
             <a:endParaRPr lang="en-US" sz="1300" dirty="0"/>
           </a:p>
@@ -6461,7 +6460,7 @@
                 <a:ea typeface="Calibri" pitchFamily="34" charset="-122"/>
                 <a:cs typeface="Calibri" pitchFamily="34" charset="-120"/>
               </a:rPr>
-              <a:t>📜  Conversation history panel</a:t>
+              <a:t>📜  Dark / light panel themes</a:t>
             </a:r>
             <a:endParaRPr lang="en-US" sz="1300" dirty="0"/>
           </a:p>
@@ -6500,7 +6499,7 @@
                 <a:ea typeface="Calibri" pitchFamily="34" charset="-122"/>
                 <a:cs typeface="Calibri" pitchFamily="34" charset="-120"/>
               </a:rPr>
-              <a:t>🚀  Auto-start on Windows login</a:t>
+              <a:t>🚀  Auto-start + update alerts</a:t>
             </a:r>
             <a:endParaRPr lang="en-US" sz="1300" dirty="0"/>
           </a:p>
@@ -6770,7 +6769,7 @@
                 <a:ea typeface="Calibri" pitchFamily="34" charset="-122"/>
                 <a:cs typeface="Calibri" pitchFamily="34" charset="-120"/>
               </a:rPr>
-              <a:t>🖥  Multi-monitor support</a:t>
+              <a:t>🖥  Voice replies — BEBO talks back</a:t>
             </a:r>
             <a:endParaRPr lang="en-US" sz="1300" dirty="0"/>
           </a:p>
@@ -7467,7 +7466,7 @@
                 <a:ea typeface="Calibri" pitchFamily="34" charset="-122"/>
                 <a:cs typeface="Calibri" pitchFamily="34" charset="-120"/>
               </a:rPr>
-              <a:t>14,400 requests/day, no credit card, no subscription, no data stored anywhere</a:t>
+              <a:t>1,000 requests/day, no credit card, no subscription, no data stored anywhere</a:t>
             </a:r>
             <a:endParaRPr lang="en-US" sz="1100" dirty="0"/>
           </a:p>
@@ -8262,7 +8261,7 @@
                 <a:ea typeface="Calibri" pitchFamily="34" charset="-122"/>
                 <a:cs typeface="Calibri" pitchFamily="34" charset="-120"/>
               </a:rPr>
-              <a:t>Built with Electron  •  Groq  •  Llama 3.3 70B  •  Claude AI</a:t>
+              <a:t>Built with Electron  •  Groq  •  GPT-OSS 120B  •  Claude AI</a:t>
             </a:r>
             <a:endParaRPr lang="en-US" sz="1100" dirty="0"/>
           </a:p>
@@ -9250,7 +9249,7 @@
                 <a:ea typeface="Calibri" pitchFamily="34" charset="-122"/>
                 <a:cs typeface="Calibri" pitchFamily="34" charset="-120"/>
               </a:rPr>
-              <a:t>14,400 requests / day</a:t>
+              <a:t>1,000 requests / day</a:t>
             </a:r>
             <a:endParaRPr lang="en-US" sz="1400" dirty="0"/>
           </a:p>
@@ -10742,7 +10741,7 @@
                 <a:ea typeface="Calibri" pitchFamily="34" charset="-122"/>
                 <a:cs typeface="Calibri" pitchFamily="34" charset="-120"/>
               </a:rPr>
-              <a:t>14,400×/day</a:t>
+              <a:t>1,000×/day</a:t>
             </a:r>
             <a:endParaRPr lang="en-US" sz="900" dirty="0"/>
           </a:p>
@@ -12605,7 +12604,7 @@
                 <a:ea typeface="Calibri" pitchFamily="34" charset="-122"/>
                 <a:cs typeface="Calibri" pitchFamily="34" charset="-120"/>
               </a:rPr>
-              <a:t>BEBO uses Llama 3.3 70B via Groq. Quality is competitive — not #1 — but expert prompts built into every button close the gap significantly for daily tasks.</a:t>
+              <a:t>BEBO uses GPT-OSS 120B via Groq. Quality is competitive — not #1 — but expert prompts built into every button close the gap significantly for daily tasks.</a:t>
             </a:r>
             <a:endParaRPr lang="en-US" sz="1000" dirty="0"/>
           </a:p>
@@ -13209,7 +13208,7 @@
                 <a:ea typeface="Calibri" pitchFamily="34" charset="-122"/>
                 <a:cs typeface="Calibri" pitchFamily="34" charset="-120"/>
               </a:rPr>
-              <a:t>14,400 requests/day on Groq free tier.</a:t>
+              <a:t>1,000 requests/day on Groq free tier.</a:t>
             </a:r>
             <a:endParaRPr lang="en-US" sz="1100" dirty="0"/>
           </a:p>
@@ -13226,7 +13225,7 @@
                 <a:ea typeface="Calibri" pitchFamily="34" charset="-122"/>
                 <a:cs typeface="Calibri" pitchFamily="34" charset="-120"/>
               </a:rPr>
-              <a:t>Claude gives you 20. BEBO gives you 14,400.</a:t>
+              <a:t>Claude gives you 20. BEBO gives you 1,000.</a:t>
             </a:r>
             <a:endParaRPr lang="en-US" sz="1100" dirty="0"/>
           </a:p>
@@ -14432,7 +14431,7 @@
                           </a:solidFill>
                           <a:latin typeface="Calibri"/>
                         </a:rPr>
-                        <a:t>BEBO  (Groq + Llama 3.3 70B)</a:t>
+                        <a:t>BEBO  (Groq + GPT-OSS 120B)</a:t>
                       </a:r>
                     </a:p>
                   </a:txBody>
@@ -14455,7 +14454,7 @@
                           </a:solidFill>
                           <a:latin typeface="Calibri"/>
                         </a:rPr>
-                        <a:t>800–1000</a:t>
+                        <a:t>~500</a:t>
                       </a:r>
                     </a:p>
                   </a:txBody>
@@ -14478,7 +14477,7 @@
                           </a:solidFill>
                           <a:latin typeface="Calibri"/>
                         </a:rPr>
-                        <a:t>0.3–0.5s ★</a:t>
+                        <a:t>0.4–0.6s ★</a:t>
                       </a:r>
                     </a:p>
                   </a:txBody>
@@ -17148,7 +17147,7 @@
                 <a:ea typeface="Calibri" pitchFamily="34" charset="-122"/>
                 <a:cs typeface="Calibri" pitchFamily="34" charset="-120"/>
               </a:rPr>
-              <a:t>Llama 3.3 70B</a:t>
+              <a:t>GPT-OSS 120B</a:t>
             </a:r>
             <a:endParaRPr lang="en-US" sz="1200" dirty="0"/>
           </a:p>
@@ -19732,7 +19731,7 @@
                 <a:ea typeface="Calibri" pitchFamily="34" charset="-122"/>
                 <a:cs typeface="Calibri" pitchFamily="34" charset="-120"/>
               </a:rPr>
-              <a:t>All powered by Llama 3.3 70B  •  14,400 free requests/day via Groq  •  No credit card</a:t>
+              <a:t>All powered by GPT-OSS 120B  •  1,000 free requests/day via Groq  •  No credit card</a:t>
             </a:r>
             <a:endParaRPr lang="en-US" sz="1100" dirty="0"/>
           </a:p>
@@ -20439,7 +20438,7 @@
                 <a:ea typeface="Calibri" pitchFamily="34" charset="-122"/>
                 <a:cs typeface="Calibri" pitchFamily="34" charset="-120"/>
               </a:rPr>
-              <a:t>Llama 3.3 70B</a:t>
+              <a:t>GPT-OSS 120B</a:t>
             </a:r>
             <a:endParaRPr lang="en-US" sz="1400" dirty="0"/>
           </a:p>
@@ -20478,7 +20477,7 @@
                 <a:ea typeface="Calibri" pitchFamily="34" charset="-122"/>
                 <a:cs typeface="Calibri" pitchFamily="34" charset="-120"/>
               </a:rPr>
-              <a:t>Meta's best open-source large language model</a:t>
+              <a:t>OpenAI's open-weight large language model</a:t>
             </a:r>
             <a:endParaRPr lang="en-US" sz="1100" dirty="0"/>
           </a:p>
@@ -24111,7 +24110,7 @@
                 <a:ea typeface="Calibri" pitchFamily="34" charset="-122"/>
                 <a:cs typeface="Calibri" pitchFamily="34" charset="-120"/>
               </a:rPr>
-              <a:t>Why Groq + Llama 3.3 70B?</a:t>
+              <a:t>Why Groq + GPT-OSS 120B?</a:t>
             </a:r>
             <a:endParaRPr lang="en-US" sz="3600" dirty="0"/>
           </a:p>
@@ -24328,7 +24327,7 @@
                 <a:ea typeface="Calibri" pitchFamily="34" charset="-122"/>
                 <a:cs typeface="Calibri" pitchFamily="34" charset="-120"/>
               </a:rPr>
-              <a:t>Groq + Llama 3.3</a:t>
+              <a:t>Groq + GPT-OSS</a:t>
             </a:r>
             <a:endParaRPr lang="en-US" sz="1300" dirty="0"/>
           </a:p>
@@ -24479,7 +24478,7 @@
                 <a:ea typeface="Calibri" pitchFamily="34" charset="-122"/>
                 <a:cs typeface="Calibri" pitchFamily="34" charset="-120"/>
               </a:rPr>
-              <a:t>14,400 / day ✅</a:t>
+              <a:t>1,000 / day ✅</a:t>
             </a:r>
             <a:endParaRPr lang="en-US" sz="1200" dirty="0"/>
           </a:p>
@@ -25309,7 +25308,7 @@
                 <a:ea typeface="Calibri" pitchFamily="34" charset="-122"/>
                 <a:cs typeface="Calibri" pitchFamily="34" charset="-120"/>
               </a:rPr>
-              <a:t>14,400 free requests/day = ~10 AI tasks per minute, every minute, all day</a:t>
+              <a:t>1,000 free requests/day = ~40 AI tasks per hour, all day, every day</a:t>
             </a:r>
             <a:endParaRPr lang="en-US" sz="1300" dirty="0"/>
           </a:p>

</xml_diff>